<commit_message>
feat: reformulacao estrutural para 9 aulas e enriquecimento teorico dos notebooks
</commit_message>
<xml_diff>
--- a/aulas/aula-06-alocacao/slides-aula-06-alocacao.pptx
+++ b/aulas/aula-06-alocacao/slides-aula-06-alocacao.pptx
@@ -3439,7 +3439,7 @@
                   <a:srgbClr val="F0F4F8"/>
                 </a:solidFill>
               </a:rPr>
-              <a:t>  Equal-weight (1/N): simplicidade, robustez e o resultado surpresa de DeMiguel (2009)</a:t>
+              <a:t>  Equal-weight (1/N): simplicidade, robustez e o resultado de DeMiguel (2009)</a:t>
             </a:r>
           </a:p>
           <a:p>
@@ -3454,7 +3454,7 @@
                   <a:srgbClr val="F0F4F8"/>
                 </a:solidFill>
               </a:rPr>
-              <a:t>  Vol-weight: reduzir contribuicao de ativos mais arriscados ao risco total</a:t>
+              <a:t>  Otimizacao de Markowitz (Teoria Moderna de Portfolio): trade-off risco-retorno</a:t>
             </a:r>
           </a:p>
           <a:p>
@@ -3469,7 +3469,7 @@
                   <a:srgbClr val="F0F4F8"/>
                 </a:solidFill>
               </a:rPr>
-              <a:t>  Otimizacao de Markowitz: teoria da fronteira eficiente vs pratica</a:t>
+              <a:t>  Instabilidade dos pesos teoricos e a necessidade de restricoes (bounds, caps)</a:t>
             </a:r>
           </a:p>
           <a:p>
@@ -3484,7 +3484,7 @@
                   <a:srgbClr val="F0F4F8"/>
                 </a:solidFill>
               </a:rPr>
-              <a:t>  Comparar as tres abordagens no mesmo sinal e tirar conclusoes</a:t>
+              <a:t>  Comparar as duas abordagens no mesmo sinal e tirar conclusoes</a:t>
             </a:r>
           </a:p>
         </p:txBody>
@@ -3699,7 +3699,7 @@
                   <a:srgbClr val="F0F4F8"/>
                 </a:solidFill>
               </a:rPr>
-              <a:t>~30 min de teoria + ~90 min de live coding</a:t>
+              <a:t>20 min de teoria + 40 min de live coding</a:t>
             </a:r>
           </a:p>
         </p:txBody>
@@ -3872,7 +3872,7 @@
                   <a:srgbClr val="0D1B3E"/>
                 </a:solidFill>
               </a:rPr>
-              <a:t>  Vol-weight: logica do risk parity simplificado</a:t>
+              <a:t>  Markowitz: onde a teoria encontra a realidade</a:t>
             </a:r>
           </a:p>
           <a:p>
@@ -3887,7 +3887,7 @@
                   <a:srgbClr val="0D1B3E"/>
                 </a:solidFill>
               </a:rPr>
-              <a:t>  Markowitz: onde a teoria encontra a realidade</a:t>
+              <a:t>  Instabilidade dos pesos e erro de estimativa</a:t>
             </a:r>
           </a:p>
           <a:p>
@@ -3902,7 +3902,7 @@
                   <a:srgbClr val="0D1B3E"/>
                 </a:solidFill>
               </a:rPr>
-              <a:t>  Turnover: custo oculto da rebalanceamento</a:t>
+              <a:t>  Como regularizar: restricoes e limites de peso</a:t>
             </a:r>
           </a:p>
         </p:txBody>
@@ -4075,7 +4075,7 @@
                   <a:srgbClr val="0D1B3E"/>
                 </a:solidFill>
               </a:rPr>
-              <a:t>  Implementar vol-weight (1/volatilidade normalizada)</a:t>
+              <a:t>  Implementar Markowitz otimizado (scipy minimize)</a:t>
             </a:r>
           </a:p>
           <a:p>
@@ -4090,7 +4090,7 @@
                   <a:srgbClr val="0D1B3E"/>
                 </a:solidFill>
               </a:rPr>
-              <a:t>  Implementar MV otimizado (scipy minimize)</a:t>
+              <a:t>  Impor restricoes de soma=1 e bounds (0 a 20%)</a:t>
             </a:r>
           </a:p>
           <a:p>
@@ -4105,7 +4105,7 @@
                   <a:srgbClr val="0D1B3E"/>
                 </a:solidFill>
               </a:rPr>
-              <a:t>  Comparar metricas das tres abordagens</a:t>
+              <a:t>  Comparar metricas e turnover das duas abordagens</a:t>
             </a:r>
           </a:p>
           <a:p>
@@ -4120,7 +4120,7 @@
                   <a:srgbClr val="0D1B3E"/>
                 </a:solidFill>
               </a:rPr>
-              <a:t>  Analisar turnover e concentracao de cada esquema</a:t>
+              <a:t>  Analisar turnover e concentracao de pesos</a:t>
             </a:r>
           </a:p>
         </p:txBody>
@@ -4301,7 +4301,7 @@
                   <a:srgbClr val="FFFFFF"/>
                 </a:solidFill>
               </a:rPr>
-              <a:t>Esquemas de Alocacao — Tres Abordagens</a:t>
+              <a:t>Esquemas de Alocacao — Duas Abordagens</a:t>
             </a:r>
           </a:p>
         </p:txBody>
@@ -4335,7 +4335,7 @@
                   <a:srgbClr val="F0F4F8"/>
                 </a:solidFill>
               </a:rPr>
-              <a:t>Da mais simples a mais sofisticada — nem sempre a mais complexa vence</a:t>
+              <a:t>Da mais simples a mais sofisticada — a importância das restrições</a:t>
             </a:r>
           </a:p>
         </p:txBody>
@@ -4369,7 +4369,7 @@
                   <a:srgbClr val="0D1B3E"/>
                 </a:solidFill>
               </a:rPr>
-              <a:t>A alocacao de capital entre os ativos selecionados e uma decisao separada do sinal. Diferentes esquemas de pesagem podem ter grande impacto no Sharpe, drawdown e turnover — e a melhor escolha frequentemente nao e a mais matematicamente sofisticada.</a:t>
+              <a:t>A alocacao de capital entre os ativos selecionados e uma decisao separada do sinal. Diferentes esquemas de pesagem podem ter grande impacto no Sharpe, drawdown e turnover — e a melhor escolha frequentemente requer restricoes pragmaticas.</a:t>
             </a:r>
           </a:p>
         </p:txBody>
@@ -4570,7 +4570,7 @@
                   <a:srgbClr val="0D1B3E"/>
                 </a:solidFill>
               </a:rPr>
-              <a:t>  Peso de cada acao: 1 / n_acoes_selecionadas</a:t>
+              <a:t>  Peso de cada acao: 1 / n_top (ex: 10%)</a:t>
             </a:r>
           </a:p>
           <a:p>
@@ -4708,7 +4708,7 @@
             <a:avLst/>
           </a:prstGeom>
           <a:solidFill>
-            <a:srgbClr val="1A6EAE"/>
+            <a:srgbClr val="C0392B"/>
           </a:solidFill>
           <a:ln>
             <a:noFill/>
@@ -4765,7 +4765,7 @@
                   <a:srgbClr val="FFFFFF"/>
                 </a:solidFill>
               </a:rPr>
-              <a:t>Vol-Weight (Risk Parity simples)</a:t>
+              <a:t>Markowitz Puro (MV)</a:t>
             </a:r>
           </a:p>
         </p:txBody>
@@ -4803,7 +4803,7 @@
                   <a:srgbClr val="0D1B3E"/>
                 </a:solidFill>
               </a:rPr>
-              <a:t>  Peso proporcional a 1/volatilidade_historica</a:t>
+              <a:t>  Maximizar Sharpe Ratio: max E[r]/σ</a:t>
             </a:r>
           </a:p>
           <a:p>
@@ -4818,7 +4818,7 @@
                   <a:srgbClr val="0D1B3E"/>
                 </a:solidFill>
               </a:rPr>
-              <a:t>  Acoes mais volateis recebem peso menor</a:t>
+              <a:t>  Requer estimacao de vetor de retornos e matriz Σ</a:t>
             </a:r>
           </a:p>
           <a:p>
@@ -4833,7 +4833,7 @@
                   <a:srgbClr val="0D1B3E"/>
                 </a:solidFill>
               </a:rPr>
-              <a:t>  Logica: equalizar contribuicao ao risco (nao ao capital)</a:t>
+              <a:t>  Instabilidade: extremamente sensivel a erros de estimacao</a:t>
             </a:r>
           </a:p>
           <a:p>
@@ -4848,7 +4848,7 @@
                   <a:srgbClr val="0D1B3E"/>
                 </a:solidFill>
               </a:rPr>
-              <a:t>  Vol estimada: desvio-padrao dos ultimos 63 dias uteis</a:t>
+              <a:t>  Resultado real: pesos ultra concentrados in poucos ativos</a:t>
             </a:r>
           </a:p>
           <a:p>
@@ -4863,7 +4863,7 @@
                   <a:srgbClr val="0D1B3E"/>
                 </a:solidFill>
               </a:rPr>
-              <a:t>  Pesos normalizados: somam 1 (long-only, sem alavancagem)</a:t>
+              <a:t>  Turnover insustentavel e pesos oscilando agressivamente</a:t>
             </a:r>
           </a:p>
           <a:p>
@@ -4878,7 +4878,7 @@
                   <a:srgbClr val="0D1B3E"/>
                 </a:solidFill>
               </a:rPr>
-              <a:t>  Reduz dependencia de acoes muito volateis (ex: small caps)</a:t>
+              <a:t>  Na pratica: inviavel sem regularizacao robusta</a:t>
             </a:r>
           </a:p>
         </p:txBody>
@@ -4941,7 +4941,7 @@
             <a:avLst/>
           </a:prstGeom>
           <a:solidFill>
-            <a:srgbClr val="C0392B"/>
+            <a:srgbClr val="0D1B3E"/>
           </a:solidFill>
           <a:ln>
             <a:noFill/>
@@ -4998,7 +4998,7 @@
                   <a:srgbClr val="FFFFFF"/>
                 </a:solidFill>
               </a:rPr>
-              <a:t>Markowitz (MV Otimizado)</a:t>
+              <a:t>Markowitz Restrito (Long-Only + Bounds)</a:t>
             </a:r>
           </a:p>
         </p:txBody>
@@ -5036,7 +5036,7 @@
                   <a:srgbClr val="0D1B3E"/>
                 </a:solidFill>
               </a:rPr>
-              <a:t>  Maximizar Sharpe: max E[r]/σ sujeito a w &gt;= 0, sum(w) = 1</a:t>
+              <a:t>  Maximizar Sharpe sujeito a restricoes realistas</a:t>
             </a:r>
           </a:p>
           <a:p>
@@ -5051,7 +5051,7 @@
                   <a:srgbClr val="0D1B3E"/>
                 </a:solidFill>
               </a:rPr>
-              <a:t>  Requer estimacao de vetor de retornos esperados e matriz Σ</a:t>
+              <a:t>  Soma dos pesos = 1 (100% alocado, sem alavancagem)</a:t>
             </a:r>
           </a:p>
           <a:p>
@@ -5066,7 +5066,7 @@
                   <a:srgbClr val="0D1B3E"/>
                 </a:solidFill>
               </a:rPr>
-              <a:t>  Problema: parametros estimados com erro amostral grande</a:t>
+              <a:t>  Bounds: limites de peso por ativo (ex: entre 0% e 20%)</a:t>
             </a:r>
           </a:p>
           <a:p>
@@ -5081,7 +5081,7 @@
                   <a:srgbClr val="0D1B3E"/>
                 </a:solidFill>
               </a:rPr>
-              <a:t>  Resultado: pesos concentrados e instáveis entre periodos</a:t>
+              <a:t>  Evita concentracao excessiva e reduz instabilidade</a:t>
             </a:r>
           </a:p>
           <a:p>
@@ -5096,7 +5096,7 @@
                   <a:srgbClr val="0D1B3E"/>
                 </a:solidFill>
               </a:rPr>
-              <a:t>  Turnover muito alto: custo de transacao elimina o alpha teorico</a:t>
+              <a:t>  Turnover significativamente menor que a versao pura</a:t>
             </a:r>
           </a:p>
           <a:p>
@@ -5111,7 +5111,7 @@
                   <a:srgbClr val="0D1B3E"/>
                 </a:solidFill>
               </a:rPr>
-              <a:t>  Na pratica: regularizacao (Black-Litterman, shrinkage) e necessaria</a:t>
+              <a:t>  Otimizacao feita via scipy.optimize.minimize</a:t>
             </a:r>
           </a:p>
         </p:txBody>
@@ -5145,7 +5145,7 @@
                   <a:srgbClr val="77889A"/>
                 </a:solidFill>
               </a:rPr>
-              <a:t>Ref.: DeMiguel, V., Garlappi, L. &amp; Uppal, R. (2009). Optimal Versus Naive Diversification. Review of Financial Studies, 22(5), 1915–1953</a:t>
+              <a:t>Ref.: DeMiguel, V., Garlappi, L. &amp; Uppal, R. (2009). Optimal Versus Naive Diversification. RFS, 22(5)</a:t>
             </a:r>
           </a:p>
         </p:txBody>
@@ -5607,7 +5607,7 @@
                   <a:srgbClr val="0D1B3E"/>
                 </a:solidFill>
               </a:rPr>
-              <a:t>  Vol-weight: turnover similar ao EW, pesos flutuam com vol</a:t>
+              <a:t>  Markowitz puro: pesos mudam drasticamente, turnover de 60-100%</a:t>
             </a:r>
           </a:p>
           <a:p>
@@ -5622,7 +5622,7 @@
                   <a:srgbClr val="0D1B3E"/>
                 </a:solidFill>
               </a:rPr>
-              <a:t>  Markowitz: turnover muito alto (60-100%) — inviavel sem restricoes</a:t>
+              <a:t>  Markowitz restrito: bounds [0, 0.20] seguram turnover e evitam giro excessivo</a:t>
             </a:r>
           </a:p>
         </p:txBody>
@@ -5812,7 +5812,7 @@
                   <a:srgbClr val="0D1B3E"/>
                 </a:solidFill>
               </a:rPr>
-              <a:t>  Pratica: testar diferentes frequencias (mensal vs bimestral)</a:t>
+              <a:t>  Pratica: restricoes estritas ajudam a manter a viabilidade</a:t>
             </a:r>
           </a:p>
         </p:txBody>
@@ -5846,7 +5846,7 @@
                   <a:srgbClr val="77889A"/>
                 </a:solidFill>
               </a:rPr>
-              <a:t>Ref.: Keim, D.B. &amp; Madhavan, A. (1997). Transactions Costs and Investment Style. J. of Financial Economics, 46(3), 265–292</a:t>
+              <a:t>Ref.: Keim, D.B. &amp; Madhavan, A. (1997). Transactions Costs and Investment Style. JFE, 46(3)</a:t>
             </a:r>
           </a:p>
         </p:txBody>
@@ -6234,22 +6234,7 @@
                   <a:srgbClr val="0D1B3E"/>
                 </a:solidFill>
               </a:rPr>
-              <a:t>  pesos_vol_weight(sinal, ret_diarios, n_top=10) — 1/vol, normalizado</a:t>
-            </a:r>
-          </a:p>
-          <a:p>
-            <a:pPr>
-              <a:spcBef>
-                <a:spcPts val="900"/>
-              </a:spcBef>
-            </a:pPr>
-            <a:r>
-              <a:rPr sz="1300">
-                <a:solidFill>
-                  <a:srgbClr val="0D1B3E"/>
-                </a:solidFill>
-              </a:rPr>
-              <a:t>  pesos_markowitz(sinal, ret_mensais, n_top=10) — scipy optimize + restricoes</a:t>
+              <a:t>  pesos_markowitz_restrito(sinal, ret_mensais, n_top=10, limit=0.20) — scipy optimize + restricoes</a:t>
             </a:r>
           </a:p>
           <a:p>
@@ -6539,7 +6524,7 @@
                   <a:srgbClr val="0D1B3E"/>
                 </a:solidFill>
               </a:rPr>
-              <a:t>  dados/pesos_v1.parquet (atualizado com as 3 versoes)</a:t>
+              <a:t>  dados/pesos_v1.parquet (atualizado com EW e Markowitz)</a:t>
             </a:r>
           </a:p>
           <a:p>

</xml_diff>